<commit_message>
fairness:class note drafts and new notebook
</commit_message>
<xml_diff>
--- a/content/chapter3/images/prep.pptx
+++ b/content/chapter3/images/prep.pptx
@@ -5,8 +5,8 @@
     <p:sldMasterId id="2147483648" r:id="rId1"/>
   </p:sldMasterIdLst>
   <p:sldIdLst>
-    <p:sldId id="256" r:id="rId2"/>
-    <p:sldId id="257" r:id="rId3"/>
+    <p:sldId id="257" r:id="rId2"/>
+    <p:sldId id="258" r:id="rId3"/>
   </p:sldIdLst>
   <p:sldSz cx="12192000" cy="6858000"/>
   <p:notesSz cx="6858000" cy="9144000"/>
@@ -105,6 +105,11 @@
       </a:defRPr>
     </a:lvl9pPr>
   </p:defaultTextStyle>
+  <p:extLst>
+    <p:ext uri="{EFAFB233-063F-42B5-8137-9DF3F51BA10A}">
+      <p15:sldGuideLst xmlns:p15="http://schemas.microsoft.com/office/powerpoint/2012/main"/>
+    </p:ext>
+  </p:extLst>
 </p:presentation>
 </file>
 
@@ -255,7 +260,7 @@
           <a:p>
             <a:fld id="{19FDCBB3-139F-304F-BF55-F9289371638F}" type="datetimeFigureOut">
               <a:rPr lang="en-US" smtClean="0"/>
-              <a:t>6/12/26</a:t>
+              <a:t>6/18/26</a:t>
             </a:fld>
             <a:endParaRPr lang="en-US"/>
           </a:p>
@@ -453,7 +458,7 @@
           <a:p>
             <a:fld id="{19FDCBB3-139F-304F-BF55-F9289371638F}" type="datetimeFigureOut">
               <a:rPr lang="en-US" smtClean="0"/>
-              <a:t>6/12/26</a:t>
+              <a:t>6/18/26</a:t>
             </a:fld>
             <a:endParaRPr lang="en-US"/>
           </a:p>
@@ -661,7 +666,7 @@
           <a:p>
             <a:fld id="{19FDCBB3-139F-304F-BF55-F9289371638F}" type="datetimeFigureOut">
               <a:rPr lang="en-US" smtClean="0"/>
-              <a:t>6/12/26</a:t>
+              <a:t>6/18/26</a:t>
             </a:fld>
             <a:endParaRPr lang="en-US"/>
           </a:p>
@@ -859,7 +864,7 @@
           <a:p>
             <a:fld id="{19FDCBB3-139F-304F-BF55-F9289371638F}" type="datetimeFigureOut">
               <a:rPr lang="en-US" smtClean="0"/>
-              <a:t>6/12/26</a:t>
+              <a:t>6/18/26</a:t>
             </a:fld>
             <a:endParaRPr lang="en-US"/>
           </a:p>
@@ -1134,7 +1139,7 @@
           <a:p>
             <a:fld id="{19FDCBB3-139F-304F-BF55-F9289371638F}" type="datetimeFigureOut">
               <a:rPr lang="en-US" smtClean="0"/>
-              <a:t>6/12/26</a:t>
+              <a:t>6/18/26</a:t>
             </a:fld>
             <a:endParaRPr lang="en-US"/>
           </a:p>
@@ -1399,7 +1404,7 @@
           <a:p>
             <a:fld id="{19FDCBB3-139F-304F-BF55-F9289371638F}" type="datetimeFigureOut">
               <a:rPr lang="en-US" smtClean="0"/>
-              <a:t>6/12/26</a:t>
+              <a:t>6/18/26</a:t>
             </a:fld>
             <a:endParaRPr lang="en-US"/>
           </a:p>
@@ -1811,7 +1816,7 @@
           <a:p>
             <a:fld id="{19FDCBB3-139F-304F-BF55-F9289371638F}" type="datetimeFigureOut">
               <a:rPr lang="en-US" smtClean="0"/>
-              <a:t>6/12/26</a:t>
+              <a:t>6/18/26</a:t>
             </a:fld>
             <a:endParaRPr lang="en-US"/>
           </a:p>
@@ -1952,7 +1957,7 @@
           <a:p>
             <a:fld id="{19FDCBB3-139F-304F-BF55-F9289371638F}" type="datetimeFigureOut">
               <a:rPr lang="en-US" smtClean="0"/>
-              <a:t>6/12/26</a:t>
+              <a:t>6/18/26</a:t>
             </a:fld>
             <a:endParaRPr lang="en-US"/>
           </a:p>
@@ -2065,7 +2070,7 @@
           <a:p>
             <a:fld id="{19FDCBB3-139F-304F-BF55-F9289371638F}" type="datetimeFigureOut">
               <a:rPr lang="en-US" smtClean="0"/>
-              <a:t>6/12/26</a:t>
+              <a:t>6/18/26</a:t>
             </a:fld>
             <a:endParaRPr lang="en-US"/>
           </a:p>
@@ -2376,7 +2381,7 @@
           <a:p>
             <a:fld id="{19FDCBB3-139F-304F-BF55-F9289371638F}" type="datetimeFigureOut">
               <a:rPr lang="en-US" smtClean="0"/>
-              <a:t>6/12/26</a:t>
+              <a:t>6/18/26</a:t>
             </a:fld>
             <a:endParaRPr lang="en-US"/>
           </a:p>
@@ -2664,7 +2669,7 @@
           <a:p>
             <a:fld id="{19FDCBB3-139F-304F-BF55-F9289371638F}" type="datetimeFigureOut">
               <a:rPr lang="en-US" smtClean="0"/>
-              <a:t>6/12/26</a:t>
+              <a:t>6/18/26</a:t>
             </a:fld>
             <a:endParaRPr lang="en-US"/>
           </a:p>
@@ -2905,7 +2910,7 @@
           <a:p>
             <a:fld id="{19FDCBB3-139F-304F-BF55-F9289371638F}" type="datetimeFigureOut">
               <a:rPr lang="en-US" smtClean="0"/>
-              <a:t>6/12/26</a:t>
+              <a:t>6/18/26</a:t>
             </a:fld>
             <a:endParaRPr lang="en-US"/>
           </a:p>
@@ -3310,83 +3315,6 @@
   <p:cSld>
     <p:spTree>
       <p:nvGrpSpPr>
-        <p:cNvPr id="1" name=""/>
-        <p:cNvGrpSpPr/>
-        <p:nvPr/>
-      </p:nvGrpSpPr>
-      <p:grpSpPr>
-        <a:xfrm>
-          <a:off x="0" y="0"/>
-          <a:ext cx="0" cy="0"/>
-          <a:chOff x="0" y="0"/>
-          <a:chExt cx="0" cy="0"/>
-        </a:xfrm>
-      </p:grpSpPr>
-      <p:pic>
-        <p:nvPicPr>
-          <p:cNvPr id="1026" name="Picture 2" descr="A confusion matrix displaying the four possible outcomes of a binary... |  Download Scientific Diagram">
-            <a:extLst>
-              <a:ext uri="{FF2B5EF4-FFF2-40B4-BE49-F238E27FC236}">
-                <a16:creationId xmlns:a16="http://schemas.microsoft.com/office/drawing/2014/main" id="{99FDC952-429D-9859-4EF1-B8D40679662C}"/>
-              </a:ext>
-            </a:extLst>
-          </p:cNvPr>
-          <p:cNvPicPr>
-            <a:picLocks noChangeAspect="1" noChangeArrowheads="1"/>
-          </p:cNvPicPr>
-          <p:nvPr/>
-        </p:nvPicPr>
-        <p:blipFill>
-          <a:blip r:embed="rId2">
-            <a:extLst>
-              <a:ext uri="{28A0092B-C50C-407E-A947-70E740481C1C}">
-                <a14:useLocalDpi xmlns:a14="http://schemas.microsoft.com/office/drawing/2010/main" val="0"/>
-              </a:ext>
-            </a:extLst>
-          </a:blip>
-          <a:srcRect/>
-          <a:stretch>
-            <a:fillRect/>
-          </a:stretch>
-        </p:blipFill>
-        <p:spPr bwMode="auto">
-          <a:xfrm>
-            <a:off x="769332" y="895914"/>
-            <a:ext cx="10384082" cy="4849977"/>
-          </a:xfrm>
-          <a:prstGeom prst="rect">
-            <a:avLst/>
-          </a:prstGeom>
-          <a:noFill/>
-          <a:extLst>
-            <a:ext uri="{909E8E84-426E-40DD-AFC4-6F175D3DCCD1}">
-              <a14:hiddenFill xmlns:a14="http://schemas.microsoft.com/office/drawing/2010/main">
-                <a:solidFill>
-                  <a:srgbClr val="FFFFFF"/>
-                </a:solidFill>
-              </a14:hiddenFill>
-            </a:ext>
-          </a:extLst>
-        </p:spPr>
-      </p:pic>
-    </p:spTree>
-    <p:extLst>
-      <p:ext uri="{BB962C8B-B14F-4D97-AF65-F5344CB8AC3E}">
-        <p14:creationId xmlns:p14="http://schemas.microsoft.com/office/powerpoint/2010/main" val="3442089062"/>
-      </p:ext>
-    </p:extLst>
-  </p:cSld>
-  <p:clrMapOvr>
-    <a:masterClrMapping/>
-  </p:clrMapOvr>
-</p:sld>
-</file>
-
-<file path=ppt/slides/slide2.xml><?xml version="1.0" encoding="utf-8"?>
-<p:sld xmlns:a="http://schemas.openxmlformats.org/drawingml/2006/main" xmlns:r="http://schemas.openxmlformats.org/officeDocument/2006/relationships" xmlns:p="http://schemas.openxmlformats.org/presentationml/2006/main">
-  <p:cSld>
-    <p:spTree>
-      <p:nvGrpSpPr>
         <p:cNvPr id="1" name="">
           <a:extLst>
             <a:ext uri="{FF2B5EF4-FFF2-40B4-BE49-F238E27FC236}">
@@ -3405,12 +3333,61 @@
           <a:chExt cx="0" cy="0"/>
         </a:xfrm>
       </p:grpSpPr>
+      <p:sp>
+        <p:nvSpPr>
+          <p:cNvPr id="4" name="Rectangle 3">
+            <a:extLst>
+              <a:ext uri="{FF2B5EF4-FFF2-40B4-BE49-F238E27FC236}">
+                <a16:creationId xmlns:a16="http://schemas.microsoft.com/office/drawing/2014/main" id="{F79F4333-BF77-7CCF-5347-B4C2E570A72D}"/>
+              </a:ext>
+            </a:extLst>
+          </p:cNvPr>
+          <p:cNvSpPr/>
+          <p:nvPr/>
+        </p:nvSpPr>
+        <p:spPr>
+          <a:xfrm>
+            <a:off x="0" y="10516"/>
+            <a:ext cx="12192000" cy="6858000"/>
+          </a:xfrm>
+          <a:prstGeom prst="rect">
+            <a:avLst/>
+          </a:prstGeom>
+          <a:solidFill>
+            <a:schemeClr val="bg1"/>
+          </a:solidFill>
+        </p:spPr>
+        <p:style>
+          <a:lnRef idx="2">
+            <a:schemeClr val="accent1">
+              <a:shade val="15000"/>
+            </a:schemeClr>
+          </a:lnRef>
+          <a:fillRef idx="1">
+            <a:schemeClr val="accent1"/>
+          </a:fillRef>
+          <a:effectRef idx="0">
+            <a:schemeClr val="accent1"/>
+          </a:effectRef>
+          <a:fontRef idx="minor">
+            <a:schemeClr val="lt1"/>
+          </a:fontRef>
+        </p:style>
+        <p:txBody>
+          <a:bodyPr rtlCol="0" anchor="ctr"/>
+          <a:lstStyle/>
+          <a:p>
+            <a:pPr algn="ctr"/>
+            <a:endParaRPr lang="en-US"/>
+          </a:p>
+        </p:txBody>
+      </p:sp>
       <p:grpSp>
         <p:nvGrpSpPr>
-          <p:cNvPr id="19" name="Group 18">
-            <a:extLst>
-              <a:ext uri="{FF2B5EF4-FFF2-40B4-BE49-F238E27FC236}">
-                <a16:creationId xmlns:a16="http://schemas.microsoft.com/office/drawing/2014/main" id="{CE60456A-5E57-09C5-F3C9-DA65A3B59A0D}"/>
+          <p:cNvPr id="3" name="Group 2">
+            <a:extLst>
+              <a:ext uri="{FF2B5EF4-FFF2-40B4-BE49-F238E27FC236}">
+                <a16:creationId xmlns:a16="http://schemas.microsoft.com/office/drawing/2014/main" id="{56C6B429-5398-9D44-732C-8DE9A2002274}"/>
               </a:ext>
             </a:extLst>
           </p:cNvPr>
@@ -3419,18 +3396,529 @@
         </p:nvGrpSpPr>
         <p:grpSpPr>
           <a:xfrm>
-            <a:off x="1255922" y="280713"/>
-            <a:ext cx="6314467" cy="1007572"/>
-            <a:chOff x="1255922" y="280713"/>
-            <a:chExt cx="6314467" cy="1007572"/>
+            <a:off x="572046" y="280713"/>
+            <a:ext cx="9155970" cy="6456530"/>
+            <a:chOff x="572046" y="280713"/>
+            <a:chExt cx="9155970" cy="6456530"/>
           </a:xfrm>
         </p:grpSpPr>
+        <p:grpSp>
+          <p:nvGrpSpPr>
+            <p:cNvPr id="19" name="Group 18">
+              <a:extLst>
+                <a:ext uri="{FF2B5EF4-FFF2-40B4-BE49-F238E27FC236}">
+                  <a16:creationId xmlns:a16="http://schemas.microsoft.com/office/drawing/2014/main" id="{CE60456A-5E57-09C5-F3C9-DA65A3B59A0D}"/>
+                </a:ext>
+              </a:extLst>
+            </p:cNvPr>
+            <p:cNvGrpSpPr/>
+            <p:nvPr/>
+          </p:nvGrpSpPr>
+          <p:grpSpPr>
+            <a:xfrm>
+              <a:off x="1255922" y="280713"/>
+              <a:ext cx="6314467" cy="1007572"/>
+              <a:chOff x="1255922" y="280713"/>
+              <a:chExt cx="6314467" cy="1007572"/>
+            </a:xfrm>
+          </p:grpSpPr>
+          <p:pic>
+            <p:nvPicPr>
+              <p:cNvPr id="2" name="Picture 1">
+                <a:extLst>
+                  <a:ext uri="{FF2B5EF4-FFF2-40B4-BE49-F238E27FC236}">
+                    <a16:creationId xmlns:a16="http://schemas.microsoft.com/office/drawing/2014/main" id="{CCA1BAD6-5C2F-AAE0-3A46-13145541B2DF}"/>
+                  </a:ext>
+                </a:extLst>
+              </p:cNvPr>
+              <p:cNvPicPr>
+                <a:picLocks noChangeAspect="1"/>
+              </p:cNvPicPr>
+              <p:nvPr/>
+            </p:nvPicPr>
+            <p:blipFill>
+              <a:blip r:embed="rId2"/>
+              <a:stretch>
+                <a:fillRect/>
+              </a:stretch>
+            </p:blipFill>
+            <p:spPr>
+              <a:xfrm>
+                <a:off x="1255922" y="280713"/>
+                <a:ext cx="1040710" cy="1007572"/>
+              </a:xfrm>
+              <a:prstGeom prst="rect">
+                <a:avLst/>
+              </a:prstGeom>
+            </p:spPr>
+          </p:pic>
+          <p:sp>
+            <p:nvSpPr>
+              <p:cNvPr id="9" name="TextBox 8">
+                <a:extLst>
+                  <a:ext uri="{FF2B5EF4-FFF2-40B4-BE49-F238E27FC236}">
+                    <a16:creationId xmlns:a16="http://schemas.microsoft.com/office/drawing/2014/main" id="{582623A2-F286-D414-BF23-95975B6C8BDE}"/>
+                  </a:ext>
+                </a:extLst>
+              </p:cNvPr>
+              <p:cNvSpPr txBox="1"/>
+              <p:nvPr/>
+            </p:nvSpPr>
+            <p:spPr>
+              <a:xfrm>
+                <a:off x="2732575" y="430556"/>
+                <a:ext cx="4837814" cy="707886"/>
+              </a:xfrm>
+              <a:prstGeom prst="rect">
+                <a:avLst/>
+              </a:prstGeom>
+              <a:noFill/>
+            </p:spPr>
+            <p:txBody>
+              <a:bodyPr wrap="square" rtlCol="0">
+                <a:spAutoFit/>
+              </a:bodyPr>
+              <a:lstStyle/>
+              <a:p>
+                <a:r>
+                  <a:rPr lang="en-US" sz="2000" dirty="0"/>
+                  <a:t>Same algorithmic accuracy should be </a:t>
+                </a:r>
+              </a:p>
+              <a:p>
+                <a:r>
+                  <a:rPr lang="en-US" sz="2000" dirty="0"/>
+                  <a:t>demonstrated for different groups </a:t>
+                </a:r>
+              </a:p>
+            </p:txBody>
+          </p:sp>
+        </p:grpSp>
+        <p:grpSp>
+          <p:nvGrpSpPr>
+            <p:cNvPr id="20" name="Group 19">
+              <a:extLst>
+                <a:ext uri="{FF2B5EF4-FFF2-40B4-BE49-F238E27FC236}">
+                  <a16:creationId xmlns:a16="http://schemas.microsoft.com/office/drawing/2014/main" id="{65E40157-8015-ECE6-2BA2-8883AF061A95}"/>
+                </a:ext>
+              </a:extLst>
+            </p:cNvPr>
+            <p:cNvGrpSpPr/>
+            <p:nvPr/>
+          </p:nvGrpSpPr>
+          <p:grpSpPr>
+            <a:xfrm>
+              <a:off x="1255922" y="2893671"/>
+              <a:ext cx="8472094" cy="1165506"/>
+              <a:chOff x="1255922" y="1502015"/>
+              <a:chExt cx="8472094" cy="1165506"/>
+            </a:xfrm>
+          </p:grpSpPr>
+          <p:pic>
+            <p:nvPicPr>
+              <p:cNvPr id="11" name="Picture 10">
+                <a:extLst>
+                  <a:ext uri="{FF2B5EF4-FFF2-40B4-BE49-F238E27FC236}">
+                    <a16:creationId xmlns:a16="http://schemas.microsoft.com/office/drawing/2014/main" id="{442EC779-2987-56BE-6755-FE7E1344A500}"/>
+                  </a:ext>
+                </a:extLst>
+              </p:cNvPr>
+              <p:cNvPicPr>
+                <a:picLocks noChangeAspect="1"/>
+              </p:cNvPicPr>
+              <p:nvPr/>
+            </p:nvPicPr>
+            <p:blipFill>
+              <a:blip r:embed="rId2"/>
+              <a:stretch>
+                <a:fillRect/>
+              </a:stretch>
+            </p:blipFill>
+            <p:spPr>
+              <a:xfrm>
+                <a:off x="1255922" y="1502015"/>
+                <a:ext cx="1040710" cy="1007572"/>
+              </a:xfrm>
+              <a:prstGeom prst="rect">
+                <a:avLst/>
+              </a:prstGeom>
+            </p:spPr>
+          </p:pic>
+          <p:sp>
+            <p:nvSpPr>
+              <p:cNvPr id="13" name="TextBox 12">
+                <a:extLst>
+                  <a:ext uri="{FF2B5EF4-FFF2-40B4-BE49-F238E27FC236}">
+                    <a16:creationId xmlns:a16="http://schemas.microsoft.com/office/drawing/2014/main" id="{B7524FF7-5F66-5D0C-A465-9C0584B363A1}"/>
+                  </a:ext>
+                </a:extLst>
+              </p:cNvPr>
+              <p:cNvSpPr txBox="1"/>
+              <p:nvPr/>
+            </p:nvSpPr>
+            <p:spPr>
+              <a:xfrm>
+                <a:off x="2732575" y="1651858"/>
+                <a:ext cx="6995441" cy="1015663"/>
+              </a:xfrm>
+              <a:prstGeom prst="rect">
+                <a:avLst/>
+              </a:prstGeom>
+              <a:noFill/>
+            </p:spPr>
+            <p:txBody>
+              <a:bodyPr wrap="none" rtlCol="0">
+                <a:spAutoFit/>
+              </a:bodyPr>
+              <a:lstStyle/>
+              <a:p>
+                <a:r>
+                  <a:rPr lang="en-US" sz="2000" dirty="0"/>
+                  <a:t>The most important thing is having the same true positive rate </a:t>
+                </a:r>
+              </a:p>
+              <a:p>
+                <a:r>
+                  <a:rPr lang="en-US" sz="2000" dirty="0"/>
+                  <a:t>for different groups! </a:t>
+                </a:r>
+              </a:p>
+              <a:p>
+                <a:r>
+                  <a:rPr lang="en-US" sz="2000" dirty="0">
+                    <a:solidFill>
+                      <a:schemeClr val="bg2">
+                        <a:lumMod val="75000"/>
+                      </a:schemeClr>
+                    </a:solidFill>
+                  </a:rPr>
+                  <a:t>(Equal opportunity)</a:t>
+                </a:r>
+              </a:p>
+            </p:txBody>
+          </p:sp>
+        </p:grpSp>
+        <p:grpSp>
+          <p:nvGrpSpPr>
+            <p:cNvPr id="21" name="Group 20">
+              <a:extLst>
+                <a:ext uri="{FF2B5EF4-FFF2-40B4-BE49-F238E27FC236}">
+                  <a16:creationId xmlns:a16="http://schemas.microsoft.com/office/drawing/2014/main" id="{7F1D5FB9-4037-7BA6-3B29-042E39C1CE79}"/>
+                </a:ext>
+              </a:extLst>
+            </p:cNvPr>
+            <p:cNvGrpSpPr/>
+            <p:nvPr/>
+          </p:nvGrpSpPr>
+          <p:grpSpPr>
+            <a:xfrm>
+              <a:off x="1255922" y="1479620"/>
+              <a:ext cx="7888473" cy="1323439"/>
+              <a:chOff x="1255922" y="2931225"/>
+              <a:chExt cx="7888473" cy="1323439"/>
+            </a:xfrm>
+          </p:grpSpPr>
+          <p:pic>
+            <p:nvPicPr>
+              <p:cNvPr id="12" name="Picture 11">
+                <a:extLst>
+                  <a:ext uri="{FF2B5EF4-FFF2-40B4-BE49-F238E27FC236}">
+                    <a16:creationId xmlns:a16="http://schemas.microsoft.com/office/drawing/2014/main" id="{118020E0-47CC-6AD1-59BB-B2EC54F32A26}"/>
+                  </a:ext>
+                </a:extLst>
+              </p:cNvPr>
+              <p:cNvPicPr>
+                <a:picLocks noChangeAspect="1"/>
+              </p:cNvPicPr>
+              <p:nvPr/>
+            </p:nvPicPr>
+            <p:blipFill>
+              <a:blip r:embed="rId2"/>
+              <a:stretch>
+                <a:fillRect/>
+              </a:stretch>
+            </p:blipFill>
+            <p:spPr>
+              <a:xfrm>
+                <a:off x="1255922" y="3089158"/>
+                <a:ext cx="1040710" cy="1007572"/>
+              </a:xfrm>
+              <a:prstGeom prst="rect">
+                <a:avLst/>
+              </a:prstGeom>
+            </p:spPr>
+          </p:pic>
+          <p:sp>
+            <p:nvSpPr>
+              <p:cNvPr id="14" name="TextBox 13">
+                <a:extLst>
+                  <a:ext uri="{FF2B5EF4-FFF2-40B4-BE49-F238E27FC236}">
+                    <a16:creationId xmlns:a16="http://schemas.microsoft.com/office/drawing/2014/main" id="{CA03D53F-B93D-BAB5-77B7-E60D15A511D4}"/>
+                  </a:ext>
+                </a:extLst>
+              </p:cNvPr>
+              <p:cNvSpPr txBox="1"/>
+              <p:nvPr/>
+            </p:nvSpPr>
+            <p:spPr>
+              <a:xfrm>
+                <a:off x="2732575" y="2931225"/>
+                <a:ext cx="6411820" cy="1323439"/>
+              </a:xfrm>
+              <a:prstGeom prst="rect">
+                <a:avLst/>
+              </a:prstGeom>
+              <a:noFill/>
+            </p:spPr>
+            <p:txBody>
+              <a:bodyPr wrap="none" rtlCol="0">
+                <a:spAutoFit/>
+              </a:bodyPr>
+              <a:lstStyle/>
+              <a:p>
+                <a:r>
+                  <a:rPr lang="en-US" sz="2000" dirty="0"/>
+                  <a:t>All  injustice would be solved if we stopped seeing color! </a:t>
+                </a:r>
+              </a:p>
+              <a:p>
+                <a:r>
+                  <a:rPr lang="en-US" sz="2000" dirty="0"/>
+                  <a:t>Let’s just remove race out of the equation! </a:t>
+                </a:r>
+              </a:p>
+              <a:p>
+                <a:r>
+                  <a:rPr lang="en-US" sz="2000" dirty="0">
+                    <a:solidFill>
+                      <a:schemeClr val="bg2">
+                        <a:lumMod val="75000"/>
+                      </a:schemeClr>
+                    </a:solidFill>
+                  </a:rPr>
+                  <a:t>(Fairness through unawareness)</a:t>
+                </a:r>
+              </a:p>
+              <a:p>
+                <a:endParaRPr lang="en-US" sz="2000" dirty="0"/>
+              </a:p>
+            </p:txBody>
+          </p:sp>
+        </p:grpSp>
+        <p:grpSp>
+          <p:nvGrpSpPr>
+            <p:cNvPr id="23" name="Group 22">
+              <a:extLst>
+                <a:ext uri="{FF2B5EF4-FFF2-40B4-BE49-F238E27FC236}">
+                  <a16:creationId xmlns:a16="http://schemas.microsoft.com/office/drawing/2014/main" id="{EB25B4A8-A283-4DA0-A349-38A356CE0765}"/>
+                </a:ext>
+              </a:extLst>
+            </p:cNvPr>
+            <p:cNvGrpSpPr/>
+            <p:nvPr/>
+          </p:nvGrpSpPr>
+          <p:grpSpPr>
+            <a:xfrm>
+              <a:off x="1132355" y="5571737"/>
+              <a:ext cx="7381483" cy="1165506"/>
+              <a:chOff x="1132355" y="5571737"/>
+              <a:chExt cx="7381483" cy="1165506"/>
+            </a:xfrm>
+          </p:grpSpPr>
+          <p:pic>
+            <p:nvPicPr>
+              <p:cNvPr id="15" name="Picture 14">
+                <a:extLst>
+                  <a:ext uri="{FF2B5EF4-FFF2-40B4-BE49-F238E27FC236}">
+                    <a16:creationId xmlns:a16="http://schemas.microsoft.com/office/drawing/2014/main" id="{32D5EE87-D901-33A7-B617-FA36B8E76F17}"/>
+                  </a:ext>
+                </a:extLst>
+              </p:cNvPr>
+              <p:cNvPicPr>
+                <a:picLocks noChangeAspect="1"/>
+              </p:cNvPicPr>
+              <p:nvPr/>
+            </p:nvPicPr>
+            <p:blipFill>
+              <a:blip r:embed="rId2"/>
+              <a:stretch>
+                <a:fillRect/>
+              </a:stretch>
+            </p:blipFill>
+            <p:spPr>
+              <a:xfrm>
+                <a:off x="1132355" y="5571737"/>
+                <a:ext cx="1040710" cy="1007572"/>
+              </a:xfrm>
+              <a:prstGeom prst="rect">
+                <a:avLst/>
+              </a:prstGeom>
+            </p:spPr>
+          </p:pic>
+          <p:sp>
+            <p:nvSpPr>
+              <p:cNvPr id="16" name="TextBox 15">
+                <a:extLst>
+                  <a:ext uri="{FF2B5EF4-FFF2-40B4-BE49-F238E27FC236}">
+                    <a16:creationId xmlns:a16="http://schemas.microsoft.com/office/drawing/2014/main" id="{3FC46098-4322-C506-05EF-5EAB81523E33}"/>
+                  </a:ext>
+                </a:extLst>
+              </p:cNvPr>
+              <p:cNvSpPr txBox="1"/>
+              <p:nvPr/>
+            </p:nvSpPr>
+            <p:spPr>
+              <a:xfrm>
+                <a:off x="2732575" y="5721580"/>
+                <a:ext cx="5781263" cy="1015663"/>
+              </a:xfrm>
+              <a:prstGeom prst="rect">
+                <a:avLst/>
+              </a:prstGeom>
+              <a:noFill/>
+            </p:spPr>
+            <p:txBody>
+              <a:bodyPr wrap="none" rtlCol="0">
+                <a:spAutoFit/>
+              </a:bodyPr>
+              <a:lstStyle/>
+              <a:p>
+                <a:r>
+                  <a:rPr lang="en-US" sz="2000" dirty="0"/>
+                  <a:t>I believe fairness is only achieved if the groups had </a:t>
+                </a:r>
+              </a:p>
+              <a:p>
+                <a:r>
+                  <a:rPr lang="en-US" sz="2000" dirty="0"/>
+                  <a:t>50:50 recidivism rate!</a:t>
+                </a:r>
+              </a:p>
+              <a:p>
+                <a:r>
+                  <a:rPr lang="en-US" sz="2000" dirty="0">
+                    <a:solidFill>
+                      <a:schemeClr val="bg2">
+                        <a:lumMod val="75000"/>
+                      </a:schemeClr>
+                    </a:solidFill>
+                  </a:rPr>
+                  <a:t>(Demographic parity)</a:t>
+                </a:r>
+              </a:p>
+            </p:txBody>
+          </p:sp>
+        </p:grpSp>
+        <p:grpSp>
+          <p:nvGrpSpPr>
+            <p:cNvPr id="22" name="Group 21">
+              <a:extLst>
+                <a:ext uri="{FF2B5EF4-FFF2-40B4-BE49-F238E27FC236}">
+                  <a16:creationId xmlns:a16="http://schemas.microsoft.com/office/drawing/2014/main" id="{3523A83D-2EF9-ED03-E86D-E02DD9E683BC}"/>
+                </a:ext>
+              </a:extLst>
+            </p:cNvPr>
+            <p:cNvGrpSpPr/>
+            <p:nvPr/>
+          </p:nvGrpSpPr>
+          <p:grpSpPr>
+            <a:xfrm>
+              <a:off x="1132355" y="4321879"/>
+              <a:ext cx="6779908" cy="1015663"/>
+              <a:chOff x="1132355" y="4382272"/>
+              <a:chExt cx="6779908" cy="1015663"/>
+            </a:xfrm>
+          </p:grpSpPr>
+          <p:pic>
+            <p:nvPicPr>
+              <p:cNvPr id="17" name="Picture 16">
+                <a:extLst>
+                  <a:ext uri="{FF2B5EF4-FFF2-40B4-BE49-F238E27FC236}">
+                    <a16:creationId xmlns:a16="http://schemas.microsoft.com/office/drawing/2014/main" id="{8EF3BF2C-6410-9CF8-DA16-13365B7DB0C7}"/>
+                  </a:ext>
+                </a:extLst>
+              </p:cNvPr>
+              <p:cNvPicPr>
+                <a:picLocks noChangeAspect="1"/>
+              </p:cNvPicPr>
+              <p:nvPr/>
+            </p:nvPicPr>
+            <p:blipFill>
+              <a:blip r:embed="rId2"/>
+              <a:stretch>
+                <a:fillRect/>
+              </a:stretch>
+            </p:blipFill>
+            <p:spPr>
+              <a:xfrm>
+                <a:off x="1132355" y="4386317"/>
+                <a:ext cx="1040710" cy="1007572"/>
+              </a:xfrm>
+              <a:prstGeom prst="rect">
+                <a:avLst/>
+              </a:prstGeom>
+            </p:spPr>
+          </p:pic>
+          <p:sp>
+            <p:nvSpPr>
+              <p:cNvPr id="18" name="TextBox 17">
+                <a:extLst>
+                  <a:ext uri="{FF2B5EF4-FFF2-40B4-BE49-F238E27FC236}">
+                    <a16:creationId xmlns:a16="http://schemas.microsoft.com/office/drawing/2014/main" id="{1AA42933-285D-4FD7-773C-1BB638F6A448}"/>
+                  </a:ext>
+                </a:extLst>
+              </p:cNvPr>
+              <p:cNvSpPr txBox="1"/>
+              <p:nvPr/>
+            </p:nvSpPr>
+            <p:spPr>
+              <a:xfrm>
+                <a:off x="2732575" y="4382272"/>
+                <a:ext cx="5179688" cy="1015663"/>
+              </a:xfrm>
+              <a:prstGeom prst="rect">
+                <a:avLst/>
+              </a:prstGeom>
+              <a:noFill/>
+            </p:spPr>
+            <p:txBody>
+              <a:bodyPr wrap="none" rtlCol="0">
+                <a:spAutoFit/>
+              </a:bodyPr>
+              <a:lstStyle/>
+              <a:p>
+                <a:r>
+                  <a:rPr lang="en-US" sz="2000" dirty="0"/>
+                  <a:t>If the algorithm makes any kind of mistake, </a:t>
+                </a:r>
+              </a:p>
+              <a:p>
+                <a:r>
+                  <a:rPr lang="en-US" sz="2000" dirty="0"/>
+                  <a:t>it shouldn’t affect one group more than other!</a:t>
+                </a:r>
+              </a:p>
+              <a:p>
+                <a:r>
+                  <a:rPr lang="en-US" sz="2000" dirty="0">
+                    <a:solidFill>
+                      <a:schemeClr val="bg2">
+                        <a:lumMod val="75000"/>
+                      </a:schemeClr>
+                    </a:solidFill>
+                  </a:rPr>
+                  <a:t>(Equalized odds)</a:t>
+                </a:r>
+              </a:p>
+            </p:txBody>
+          </p:sp>
+        </p:grpSp>
         <p:pic>
           <p:nvPicPr>
-            <p:cNvPr id="2" name="Picture 1">
+            <p:cNvPr id="25" name="Graphic 24" descr="Badge 1 with solid fill">
               <a:extLst>
                 <a:ext uri="{FF2B5EF4-FFF2-40B4-BE49-F238E27FC236}">
-                  <a16:creationId xmlns:a16="http://schemas.microsoft.com/office/drawing/2014/main" id="{CCA1BAD6-5C2F-AAE0-3A46-13145541B2DF}"/>
+                  <a16:creationId xmlns:a16="http://schemas.microsoft.com/office/drawing/2014/main" id="{AA1DCAFB-A6C4-3A29-1715-816A477F5405}"/>
                 </a:ext>
               </a:extLst>
             </p:cNvPr>
@@ -3440,89 +3928,33 @@
             <p:nvPr/>
           </p:nvPicPr>
           <p:blipFill>
-            <a:blip r:embed="rId2"/>
+            <a:blip>
+              <a:extLst>
+                <a:ext uri="{96DAC541-7B7A-43D3-8B79-37D633B846F1}">
+                  <asvg:svgBlip xmlns:asvg="http://schemas.microsoft.com/office/drawing/2016/SVG/main" r:embed="rId3"/>
+                </a:ext>
+              </a:extLst>
+            </a:blip>
             <a:stretch>
               <a:fillRect/>
             </a:stretch>
           </p:blipFill>
           <p:spPr>
             <a:xfrm>
-              <a:off x="1255922" y="280713"/>
-              <a:ext cx="1040710" cy="1007572"/>
+              <a:off x="572046" y="509670"/>
+              <a:ext cx="560309" cy="560309"/>
             </a:xfrm>
             <a:prstGeom prst="rect">
               <a:avLst/>
             </a:prstGeom>
           </p:spPr>
         </p:pic>
-        <p:sp>
-          <p:nvSpPr>
-            <p:cNvPr id="9" name="TextBox 8">
+        <p:pic>
+          <p:nvPicPr>
+            <p:cNvPr id="27" name="Graphic 26" descr="Badge 3 with solid fill">
               <a:extLst>
                 <a:ext uri="{FF2B5EF4-FFF2-40B4-BE49-F238E27FC236}">
-                  <a16:creationId xmlns:a16="http://schemas.microsoft.com/office/drawing/2014/main" id="{582623A2-F286-D414-BF23-95975B6C8BDE}"/>
-                </a:ext>
-              </a:extLst>
-            </p:cNvPr>
-            <p:cNvSpPr txBox="1"/>
-            <p:nvPr/>
-          </p:nvSpPr>
-          <p:spPr>
-            <a:xfrm>
-              <a:off x="2732575" y="430556"/>
-              <a:ext cx="4837814" cy="707886"/>
-            </a:xfrm>
-            <a:prstGeom prst="rect">
-              <a:avLst/>
-            </a:prstGeom>
-            <a:noFill/>
-          </p:spPr>
-          <p:txBody>
-            <a:bodyPr wrap="square" rtlCol="0">
-              <a:spAutoFit/>
-            </a:bodyPr>
-            <a:lstStyle/>
-            <a:p>
-              <a:r>
-                <a:rPr lang="en-US" sz="2000" dirty="0"/>
-                <a:t>Same algorithmic accuracy should be </a:t>
-              </a:r>
-            </a:p>
-            <a:p>
-              <a:r>
-                <a:rPr lang="en-US" sz="2000" dirty="0"/>
-                <a:t>demonstrated for different groups </a:t>
-              </a:r>
-            </a:p>
-          </p:txBody>
-        </p:sp>
-      </p:grpSp>
-      <p:grpSp>
-        <p:nvGrpSpPr>
-          <p:cNvPr id="20" name="Group 19">
-            <a:extLst>
-              <a:ext uri="{FF2B5EF4-FFF2-40B4-BE49-F238E27FC236}">
-                <a16:creationId xmlns:a16="http://schemas.microsoft.com/office/drawing/2014/main" id="{65E40157-8015-ECE6-2BA2-8883AF061A95}"/>
-              </a:ext>
-            </a:extLst>
-          </p:cNvPr>
-          <p:cNvGrpSpPr/>
-          <p:nvPr/>
-        </p:nvGrpSpPr>
-        <p:grpSpPr>
-          <a:xfrm>
-            <a:off x="1255922" y="1522480"/>
-            <a:ext cx="8612389" cy="1007572"/>
-            <a:chOff x="1255922" y="1502015"/>
-            <a:chExt cx="8612389" cy="1007572"/>
-          </a:xfrm>
-        </p:grpSpPr>
-        <p:pic>
-          <p:nvPicPr>
-            <p:cNvPr id="11" name="Picture 10">
-              <a:extLst>
-                <a:ext uri="{FF2B5EF4-FFF2-40B4-BE49-F238E27FC236}">
-                  <a16:creationId xmlns:a16="http://schemas.microsoft.com/office/drawing/2014/main" id="{442EC779-2987-56BE-6755-FE7E1344A500}"/>
+                  <a16:creationId xmlns:a16="http://schemas.microsoft.com/office/drawing/2014/main" id="{301A1793-29BE-2992-54BD-7130231E59F4}"/>
                 </a:ext>
               </a:extLst>
             </p:cNvPr>
@@ -3532,95 +3964,33 @@
             <p:nvPr/>
           </p:nvPicPr>
           <p:blipFill>
-            <a:blip r:embed="rId2"/>
+            <a:blip>
+              <a:extLst>
+                <a:ext uri="{96DAC541-7B7A-43D3-8B79-37D633B846F1}">
+                  <asvg:svgBlip xmlns:asvg="http://schemas.microsoft.com/office/drawing/2016/SVG/main" r:embed="rId4"/>
+                </a:ext>
+              </a:extLst>
+            </a:blip>
             <a:stretch>
               <a:fillRect/>
             </a:stretch>
           </p:blipFill>
           <p:spPr>
             <a:xfrm>
-              <a:off x="1255922" y="1502015"/>
-              <a:ext cx="1040710" cy="1007572"/>
+              <a:off x="592446" y="3166211"/>
+              <a:ext cx="519508" cy="519508"/>
             </a:xfrm>
             <a:prstGeom prst="rect">
               <a:avLst/>
             </a:prstGeom>
           </p:spPr>
         </p:pic>
-        <p:sp>
-          <p:nvSpPr>
-            <p:cNvPr id="13" name="TextBox 12">
+        <p:pic>
+          <p:nvPicPr>
+            <p:cNvPr id="29" name="Graphic 28" descr="Badge with solid fill">
               <a:extLst>
                 <a:ext uri="{FF2B5EF4-FFF2-40B4-BE49-F238E27FC236}">
-                  <a16:creationId xmlns:a16="http://schemas.microsoft.com/office/drawing/2014/main" id="{B7524FF7-5F66-5D0C-A465-9C0584B363A1}"/>
-                </a:ext>
-              </a:extLst>
-            </p:cNvPr>
-            <p:cNvSpPr txBox="1"/>
-            <p:nvPr/>
-          </p:nvSpPr>
-          <p:spPr>
-            <a:xfrm>
-              <a:off x="2732575" y="1651858"/>
-              <a:ext cx="7135736" cy="707886"/>
-            </a:xfrm>
-            <a:prstGeom prst="rect">
-              <a:avLst/>
-            </a:prstGeom>
-            <a:noFill/>
-          </p:spPr>
-          <p:txBody>
-            <a:bodyPr wrap="none" rtlCol="0">
-              <a:spAutoFit/>
-            </a:bodyPr>
-            <a:lstStyle/>
-            <a:p>
-              <a:r>
-                <a:rPr lang="en-US" sz="2000" dirty="0"/>
-                <a:t>The most important thing is not missing any dangerous people! </a:t>
-              </a:r>
-            </a:p>
-            <a:p>
-              <a:r>
-                <a:rPr lang="en-US" sz="2000" dirty="0">
-                  <a:solidFill>
-                    <a:schemeClr val="bg2">
-                      <a:lumMod val="75000"/>
-                    </a:schemeClr>
-                  </a:solidFill>
-                </a:rPr>
-                <a:t>(Equal opportunity)</a:t>
-              </a:r>
-            </a:p>
-          </p:txBody>
-        </p:sp>
-      </p:grpSp>
-      <p:grpSp>
-        <p:nvGrpSpPr>
-          <p:cNvPr id="21" name="Group 20">
-            <a:extLst>
-              <a:ext uri="{FF2B5EF4-FFF2-40B4-BE49-F238E27FC236}">
-                <a16:creationId xmlns:a16="http://schemas.microsoft.com/office/drawing/2014/main" id="{7F1D5FB9-4037-7BA6-3B29-042E39C1CE79}"/>
-              </a:ext>
-            </a:extLst>
-          </p:cNvPr>
-          <p:cNvGrpSpPr/>
-          <p:nvPr/>
-        </p:nvGrpSpPr>
-        <p:grpSpPr>
-          <a:xfrm>
-            <a:off x="1255922" y="2764246"/>
-            <a:ext cx="7888473" cy="1323439"/>
-            <a:chOff x="1255922" y="2931225"/>
-            <a:chExt cx="7888473" cy="1323439"/>
-          </a:xfrm>
-        </p:grpSpPr>
-        <p:pic>
-          <p:nvPicPr>
-            <p:cNvPr id="12" name="Picture 11">
-              <a:extLst>
-                <a:ext uri="{FF2B5EF4-FFF2-40B4-BE49-F238E27FC236}">
-                  <a16:creationId xmlns:a16="http://schemas.microsoft.com/office/drawing/2014/main" id="{118020E0-47CC-6AD1-59BB-B2EC54F32A26}"/>
+                  <a16:creationId xmlns:a16="http://schemas.microsoft.com/office/drawing/2014/main" id="{8EC57C48-784A-567F-26E5-6A5C50E16537}"/>
                 </a:ext>
               </a:extLst>
             </p:cNvPr>
@@ -3630,104 +4000,33 @@
             <p:nvPr/>
           </p:nvPicPr>
           <p:blipFill>
-            <a:blip r:embed="rId2"/>
+            <a:blip>
+              <a:extLst>
+                <a:ext uri="{96DAC541-7B7A-43D3-8B79-37D633B846F1}">
+                  <asvg:svgBlip xmlns:asvg="http://schemas.microsoft.com/office/drawing/2016/SVG/main" r:embed="rId5"/>
+                </a:ext>
+              </a:extLst>
+            </a:blip>
             <a:stretch>
               <a:fillRect/>
             </a:stretch>
           </p:blipFill>
           <p:spPr>
             <a:xfrm>
-              <a:off x="1255922" y="3089158"/>
-              <a:ext cx="1040710" cy="1007572"/>
+              <a:off x="579584" y="1766513"/>
+              <a:ext cx="545233" cy="545233"/>
             </a:xfrm>
             <a:prstGeom prst="rect">
               <a:avLst/>
             </a:prstGeom>
           </p:spPr>
         </p:pic>
-        <p:sp>
-          <p:nvSpPr>
-            <p:cNvPr id="14" name="TextBox 13">
+        <p:pic>
+          <p:nvPicPr>
+            <p:cNvPr id="31" name="Graphic 30" descr="Badge 4 with solid fill">
               <a:extLst>
                 <a:ext uri="{FF2B5EF4-FFF2-40B4-BE49-F238E27FC236}">
-                  <a16:creationId xmlns:a16="http://schemas.microsoft.com/office/drawing/2014/main" id="{CA03D53F-B93D-BAB5-77B7-E60D15A511D4}"/>
-                </a:ext>
-              </a:extLst>
-            </p:cNvPr>
-            <p:cNvSpPr txBox="1"/>
-            <p:nvPr/>
-          </p:nvSpPr>
-          <p:spPr>
-            <a:xfrm>
-              <a:off x="2732575" y="2931225"/>
-              <a:ext cx="6411820" cy="1323439"/>
-            </a:xfrm>
-            <a:prstGeom prst="rect">
-              <a:avLst/>
-            </a:prstGeom>
-            <a:noFill/>
-          </p:spPr>
-          <p:txBody>
-            <a:bodyPr wrap="none" rtlCol="0">
-              <a:spAutoFit/>
-            </a:bodyPr>
-            <a:lstStyle/>
-            <a:p>
-              <a:r>
-                <a:rPr lang="en-US" sz="2000" dirty="0"/>
-                <a:t>All  injustice would be solved if we stopped seeing color! </a:t>
-              </a:r>
-            </a:p>
-            <a:p>
-              <a:r>
-                <a:rPr lang="en-US" sz="2000" dirty="0"/>
-                <a:t>Let’s just remove race out of the equation! </a:t>
-              </a:r>
-            </a:p>
-            <a:p>
-              <a:r>
-                <a:rPr lang="en-US" sz="2000" dirty="0">
-                  <a:solidFill>
-                    <a:schemeClr val="bg2">
-                      <a:lumMod val="75000"/>
-                    </a:schemeClr>
-                  </a:solidFill>
-                </a:rPr>
-                <a:t>(Fairness through unawareness)</a:t>
-              </a:r>
-            </a:p>
-            <a:p>
-              <a:endParaRPr lang="en-US" sz="2000" dirty="0"/>
-            </a:p>
-          </p:txBody>
-        </p:sp>
-      </p:grpSp>
-      <p:grpSp>
-        <p:nvGrpSpPr>
-          <p:cNvPr id="23" name="Group 22">
-            <a:extLst>
-              <a:ext uri="{FF2B5EF4-FFF2-40B4-BE49-F238E27FC236}">
-                <a16:creationId xmlns:a16="http://schemas.microsoft.com/office/drawing/2014/main" id="{EB25B4A8-A283-4DA0-A349-38A356CE0765}"/>
-              </a:ext>
-            </a:extLst>
-          </p:cNvPr>
-          <p:cNvGrpSpPr/>
-          <p:nvPr/>
-        </p:nvGrpSpPr>
-        <p:grpSpPr>
-          <a:xfrm>
-            <a:off x="1132355" y="5571737"/>
-            <a:ext cx="9247698" cy="1007572"/>
-            <a:chOff x="1132355" y="5571737"/>
-            <a:chExt cx="9247698" cy="1007572"/>
-          </a:xfrm>
-        </p:grpSpPr>
-        <p:pic>
-          <p:nvPicPr>
-            <p:cNvPr id="15" name="Picture 14">
-              <a:extLst>
-                <a:ext uri="{FF2B5EF4-FFF2-40B4-BE49-F238E27FC236}">
-                  <a16:creationId xmlns:a16="http://schemas.microsoft.com/office/drawing/2014/main" id="{32D5EE87-D901-33A7-B617-FA36B8E76F17}"/>
+                  <a16:creationId xmlns:a16="http://schemas.microsoft.com/office/drawing/2014/main" id="{2F5D2E9E-B9BB-DBAA-CCA3-6C01ED914339}"/>
                 </a:ext>
               </a:extLst>
             </p:cNvPr>
@@ -3737,95 +4036,33 @@
             <p:nvPr/>
           </p:nvPicPr>
           <p:blipFill>
-            <a:blip r:embed="rId2"/>
+            <a:blip>
+              <a:extLst>
+                <a:ext uri="{96DAC541-7B7A-43D3-8B79-37D633B846F1}">
+                  <asvg:svgBlip xmlns:asvg="http://schemas.microsoft.com/office/drawing/2016/SVG/main" r:embed="rId6"/>
+                </a:ext>
+              </a:extLst>
+            </a:blip>
             <a:stretch>
               <a:fillRect/>
             </a:stretch>
           </p:blipFill>
           <p:spPr>
             <a:xfrm>
-              <a:off x="1132355" y="5571737"/>
-              <a:ext cx="1040710" cy="1007572"/>
+              <a:off x="592447" y="4569957"/>
+              <a:ext cx="519507" cy="519507"/>
             </a:xfrm>
             <a:prstGeom prst="rect">
               <a:avLst/>
             </a:prstGeom>
           </p:spPr>
         </p:pic>
-        <p:sp>
-          <p:nvSpPr>
-            <p:cNvPr id="16" name="TextBox 15">
+        <p:pic>
+          <p:nvPicPr>
+            <p:cNvPr id="33" name="Graphic 32" descr="Badge 5 with solid fill">
               <a:extLst>
                 <a:ext uri="{FF2B5EF4-FFF2-40B4-BE49-F238E27FC236}">
-                  <a16:creationId xmlns:a16="http://schemas.microsoft.com/office/drawing/2014/main" id="{3FC46098-4322-C506-05EF-5EAB81523E33}"/>
-                </a:ext>
-              </a:extLst>
-            </p:cNvPr>
-            <p:cNvSpPr txBox="1"/>
-            <p:nvPr/>
-          </p:nvSpPr>
-          <p:spPr>
-            <a:xfrm>
-              <a:off x="2732575" y="5721580"/>
-              <a:ext cx="7647478" cy="707886"/>
-            </a:xfrm>
-            <a:prstGeom prst="rect">
-              <a:avLst/>
-            </a:prstGeom>
-            <a:noFill/>
-          </p:spPr>
-          <p:txBody>
-            <a:bodyPr wrap="none" rtlCol="0">
-              <a:spAutoFit/>
-            </a:bodyPr>
-            <a:lstStyle/>
-            <a:p>
-              <a:r>
-                <a:rPr lang="en-US" sz="2000" dirty="0"/>
-                <a:t>I believe fairness is only achieved if the groups had 50:50 outcomes!</a:t>
-              </a:r>
-            </a:p>
-            <a:p>
-              <a:r>
-                <a:rPr lang="en-US" sz="2000" dirty="0">
-                  <a:solidFill>
-                    <a:schemeClr val="bg2">
-                      <a:lumMod val="75000"/>
-                    </a:schemeClr>
-                  </a:solidFill>
-                </a:rPr>
-                <a:t>(Demographic parity)</a:t>
-              </a:r>
-            </a:p>
-          </p:txBody>
-        </p:sp>
-      </p:grpSp>
-      <p:grpSp>
-        <p:nvGrpSpPr>
-          <p:cNvPr id="22" name="Group 21">
-            <a:extLst>
-              <a:ext uri="{FF2B5EF4-FFF2-40B4-BE49-F238E27FC236}">
-                <a16:creationId xmlns:a16="http://schemas.microsoft.com/office/drawing/2014/main" id="{3523A83D-2EF9-ED03-E86D-E02DD9E683BC}"/>
-              </a:ext>
-            </a:extLst>
-          </p:cNvPr>
-          <p:cNvGrpSpPr/>
-          <p:nvPr/>
-        </p:nvGrpSpPr>
-        <p:grpSpPr>
-          <a:xfrm>
-            <a:off x="1132355" y="4321879"/>
-            <a:ext cx="6779908" cy="1015663"/>
-            <a:chOff x="1132355" y="4382272"/>
-            <a:chExt cx="6779908" cy="1015663"/>
-          </a:xfrm>
-        </p:grpSpPr>
-        <p:pic>
-          <p:nvPicPr>
-            <p:cNvPr id="17" name="Picture 16">
-              <a:extLst>
-                <a:ext uri="{FF2B5EF4-FFF2-40B4-BE49-F238E27FC236}">
-                  <a16:creationId xmlns:a16="http://schemas.microsoft.com/office/drawing/2014/main" id="{8EF3BF2C-6410-9CF8-DA16-13365B7DB0C7}"/>
+                  <a16:creationId xmlns:a16="http://schemas.microsoft.com/office/drawing/2014/main" id="{0B165BA9-FD94-BF18-06B8-63DBDB4B80B7}"/>
                 </a:ext>
               </a:extLst>
             </p:cNvPr>
@@ -3835,79 +4072,348 @@
             <p:nvPr/>
           </p:nvPicPr>
           <p:blipFill>
-            <a:blip r:embed="rId2"/>
+            <a:blip>
+              <a:extLst>
+                <a:ext uri="{96DAC541-7B7A-43D3-8B79-37D633B846F1}">
+                  <asvg:svgBlip xmlns:asvg="http://schemas.microsoft.com/office/drawing/2016/SVG/main" r:embed="rId7"/>
+                </a:ext>
+              </a:extLst>
+            </a:blip>
             <a:stretch>
               <a:fillRect/>
             </a:stretch>
           </p:blipFill>
           <p:spPr>
             <a:xfrm>
-              <a:off x="1132355" y="4386317"/>
-              <a:ext cx="1040710" cy="1007572"/>
+              <a:off x="592447" y="5815770"/>
+              <a:ext cx="519507" cy="519507"/>
             </a:xfrm>
             <a:prstGeom prst="rect">
               <a:avLst/>
             </a:prstGeom>
           </p:spPr>
         </p:pic>
-        <p:sp>
-          <p:nvSpPr>
-            <p:cNvPr id="18" name="TextBox 17">
-              <a:extLst>
-                <a:ext uri="{FF2B5EF4-FFF2-40B4-BE49-F238E27FC236}">
-                  <a16:creationId xmlns:a16="http://schemas.microsoft.com/office/drawing/2014/main" id="{1AA42933-285D-4FD7-773C-1BB638F6A448}"/>
-                </a:ext>
-              </a:extLst>
-            </p:cNvPr>
-            <p:cNvSpPr txBox="1"/>
-            <p:nvPr/>
-          </p:nvSpPr>
-          <p:spPr>
-            <a:xfrm>
-              <a:off x="2732575" y="4382272"/>
-              <a:ext cx="5179688" cy="1015663"/>
-            </a:xfrm>
-            <a:prstGeom prst="rect">
-              <a:avLst/>
-            </a:prstGeom>
-            <a:noFill/>
-          </p:spPr>
-          <p:txBody>
-            <a:bodyPr wrap="none" rtlCol="0">
-              <a:spAutoFit/>
-            </a:bodyPr>
-            <a:lstStyle/>
-            <a:p>
-              <a:r>
-                <a:rPr lang="en-US" sz="2000" dirty="0"/>
-                <a:t>If the algorithm makes any kind of mistake, </a:t>
-              </a:r>
-            </a:p>
-            <a:p>
-              <a:r>
-                <a:rPr lang="en-US" sz="2000" dirty="0"/>
-                <a:t>it shouldn’t affect one group more than other!</a:t>
-              </a:r>
-            </a:p>
-            <a:p>
-              <a:r>
-                <a:rPr lang="en-US" sz="2000" dirty="0">
-                  <a:solidFill>
-                    <a:schemeClr val="bg2">
-                      <a:lumMod val="75000"/>
-                    </a:schemeClr>
-                  </a:solidFill>
-                </a:rPr>
-                <a:t>(Equalized odds)</a:t>
-              </a:r>
-            </a:p>
-          </p:txBody>
-        </p:sp>
       </p:grpSp>
     </p:spTree>
     <p:extLst>
       <p:ext uri="{BB962C8B-B14F-4D97-AF65-F5344CB8AC3E}">
         <p14:creationId xmlns:p14="http://schemas.microsoft.com/office/powerpoint/2010/main" val="1124857290"/>
+      </p:ext>
+    </p:extLst>
+  </p:cSld>
+  <p:clrMapOvr>
+    <a:masterClrMapping/>
+  </p:clrMapOvr>
+</p:sld>
+</file>
+
+<file path=ppt/slides/slide2.xml><?xml version="1.0" encoding="utf-8"?>
+<p:sld xmlns:a="http://schemas.openxmlformats.org/drawingml/2006/main" xmlns:r="http://schemas.openxmlformats.org/officeDocument/2006/relationships" xmlns:p="http://schemas.openxmlformats.org/presentationml/2006/main">
+  <p:cSld>
+    <p:spTree>
+      <p:nvGrpSpPr>
+        <p:cNvPr id="1" name="">
+          <a:extLst>
+            <a:ext uri="{FF2B5EF4-FFF2-40B4-BE49-F238E27FC236}">
+              <a16:creationId xmlns:a16="http://schemas.microsoft.com/office/drawing/2014/main" id="{72119FDC-0C36-6A53-E0C0-7413E5BBF47B}"/>
+            </a:ext>
+          </a:extLst>
+        </p:cNvPr>
+        <p:cNvGrpSpPr/>
+        <p:nvPr/>
+      </p:nvGrpSpPr>
+      <p:grpSpPr>
+        <a:xfrm>
+          <a:off x="0" y="0"/>
+          <a:ext cx="0" cy="0"/>
+          <a:chOff x="0" y="0"/>
+          <a:chExt cx="0" cy="0"/>
+        </a:xfrm>
+      </p:grpSpPr>
+      <p:sp>
+        <p:nvSpPr>
+          <p:cNvPr id="2" name="Rectangle 1">
+            <a:extLst>
+              <a:ext uri="{FF2B5EF4-FFF2-40B4-BE49-F238E27FC236}">
+                <a16:creationId xmlns:a16="http://schemas.microsoft.com/office/drawing/2014/main" id="{F633F9D5-026B-FAB5-E0AC-8D8EB1E56C59}"/>
+              </a:ext>
+            </a:extLst>
+          </p:cNvPr>
+          <p:cNvSpPr/>
+          <p:nvPr/>
+        </p:nvSpPr>
+        <p:spPr>
+          <a:xfrm>
+            <a:off x="1196788" y="1277471"/>
+            <a:ext cx="3429000" cy="874058"/>
+          </a:xfrm>
+          <a:prstGeom prst="rect">
+            <a:avLst/>
+          </a:prstGeom>
+          <a:noFill/>
+          <a:ln>
+            <a:solidFill>
+              <a:schemeClr val="accent3"/>
+            </a:solidFill>
+          </a:ln>
+        </p:spPr>
+        <p:style>
+          <a:lnRef idx="2">
+            <a:schemeClr val="accent1">
+              <a:shade val="15000"/>
+            </a:schemeClr>
+          </a:lnRef>
+          <a:fillRef idx="1">
+            <a:schemeClr val="accent1"/>
+          </a:fillRef>
+          <a:effectRef idx="0">
+            <a:schemeClr val="accent1"/>
+          </a:effectRef>
+          <a:fontRef idx="minor">
+            <a:schemeClr val="lt1"/>
+          </a:fontRef>
+        </p:style>
+        <p:txBody>
+          <a:bodyPr rtlCol="0" anchor="ctr"/>
+          <a:lstStyle/>
+          <a:p>
+            <a:pPr algn="ctr"/>
+            <a:r>
+              <a:rPr lang="en-US" b="1" dirty="0">
+                <a:solidFill>
+                  <a:schemeClr val="tx1"/>
+                </a:solidFill>
+              </a:rPr>
+              <a:t>True positive (TP)</a:t>
+            </a:r>
+          </a:p>
+          <a:p>
+            <a:pPr algn="ctr"/>
+            <a:r>
+              <a:rPr lang="en-US" dirty="0">
+                <a:solidFill>
+                  <a:schemeClr val="tx1"/>
+                </a:solidFill>
+              </a:rPr>
+              <a:t>recidivists identified</a:t>
+            </a:r>
+          </a:p>
+        </p:txBody>
+      </p:sp>
+      <p:sp>
+        <p:nvSpPr>
+          <p:cNvPr id="3" name="Rectangle 2">
+            <a:extLst>
+              <a:ext uri="{FF2B5EF4-FFF2-40B4-BE49-F238E27FC236}">
+                <a16:creationId xmlns:a16="http://schemas.microsoft.com/office/drawing/2014/main" id="{E02B09BC-3B56-0B41-5AD6-9152B8D29C8F}"/>
+              </a:ext>
+            </a:extLst>
+          </p:cNvPr>
+          <p:cNvSpPr/>
+          <p:nvPr/>
+        </p:nvSpPr>
+        <p:spPr>
+          <a:xfrm>
+            <a:off x="5006788" y="1277471"/>
+            <a:ext cx="3429000" cy="874058"/>
+          </a:xfrm>
+          <a:prstGeom prst="rect">
+            <a:avLst/>
+          </a:prstGeom>
+          <a:noFill/>
+          <a:ln>
+            <a:solidFill>
+              <a:srgbClr val="FF0000"/>
+            </a:solidFill>
+          </a:ln>
+        </p:spPr>
+        <p:style>
+          <a:lnRef idx="2">
+            <a:schemeClr val="accent1">
+              <a:shade val="15000"/>
+            </a:schemeClr>
+          </a:lnRef>
+          <a:fillRef idx="1">
+            <a:schemeClr val="accent1"/>
+          </a:fillRef>
+          <a:effectRef idx="0">
+            <a:schemeClr val="accent1"/>
+          </a:effectRef>
+          <a:fontRef idx="minor">
+            <a:schemeClr val="lt1"/>
+          </a:fontRef>
+        </p:style>
+        <p:txBody>
+          <a:bodyPr rtlCol="0" anchor="ctr"/>
+          <a:lstStyle/>
+          <a:p>
+            <a:pPr algn="ctr"/>
+            <a:r>
+              <a:rPr lang="en-US" b="1" dirty="0">
+                <a:solidFill>
+                  <a:schemeClr val="tx1"/>
+                </a:solidFill>
+              </a:rPr>
+              <a:t>False positive (FP)</a:t>
+            </a:r>
+          </a:p>
+          <a:p>
+            <a:pPr algn="ctr"/>
+            <a:r>
+              <a:rPr lang="en-US" dirty="0">
+                <a:solidFill>
+                  <a:schemeClr val="tx1"/>
+                </a:solidFill>
+              </a:rPr>
+              <a:t>…</a:t>
+            </a:r>
+          </a:p>
+        </p:txBody>
+      </p:sp>
+      <p:sp>
+        <p:nvSpPr>
+          <p:cNvPr id="4" name="Rectangle 3">
+            <a:extLst>
+              <a:ext uri="{FF2B5EF4-FFF2-40B4-BE49-F238E27FC236}">
+                <a16:creationId xmlns:a16="http://schemas.microsoft.com/office/drawing/2014/main" id="{3626A515-CFE5-494B-662E-150832A911EB}"/>
+              </a:ext>
+            </a:extLst>
+          </p:cNvPr>
+          <p:cNvSpPr/>
+          <p:nvPr/>
+        </p:nvSpPr>
+        <p:spPr>
+          <a:xfrm>
+            <a:off x="1196788" y="2554942"/>
+            <a:ext cx="3429000" cy="874058"/>
+          </a:xfrm>
+          <a:prstGeom prst="rect">
+            <a:avLst/>
+          </a:prstGeom>
+          <a:noFill/>
+          <a:ln>
+            <a:solidFill>
+              <a:srgbClr val="FF0000"/>
+            </a:solidFill>
+          </a:ln>
+        </p:spPr>
+        <p:style>
+          <a:lnRef idx="2">
+            <a:schemeClr val="accent1">
+              <a:shade val="15000"/>
+            </a:schemeClr>
+          </a:lnRef>
+          <a:fillRef idx="1">
+            <a:schemeClr val="accent1"/>
+          </a:fillRef>
+          <a:effectRef idx="0">
+            <a:schemeClr val="accent1"/>
+          </a:effectRef>
+          <a:fontRef idx="minor">
+            <a:schemeClr val="lt1"/>
+          </a:fontRef>
+        </p:style>
+        <p:txBody>
+          <a:bodyPr rtlCol="0" anchor="ctr"/>
+          <a:lstStyle/>
+          <a:p>
+            <a:pPr algn="ctr"/>
+            <a:r>
+              <a:rPr lang="en-US" b="1" dirty="0">
+                <a:solidFill>
+                  <a:schemeClr val="tx1"/>
+                </a:solidFill>
+              </a:rPr>
+              <a:t>False negative (FN)</a:t>
+            </a:r>
+          </a:p>
+          <a:p>
+            <a:pPr algn="ctr"/>
+            <a:r>
+              <a:rPr lang="en-US" b="1" dirty="0">
+                <a:solidFill>
+                  <a:schemeClr val="tx1"/>
+                </a:solidFill>
+              </a:rPr>
+              <a:t>….</a:t>
+            </a:r>
+          </a:p>
+        </p:txBody>
+      </p:sp>
+      <p:sp>
+        <p:nvSpPr>
+          <p:cNvPr id="5" name="Rectangle 4">
+            <a:extLst>
+              <a:ext uri="{FF2B5EF4-FFF2-40B4-BE49-F238E27FC236}">
+                <a16:creationId xmlns:a16="http://schemas.microsoft.com/office/drawing/2014/main" id="{B8EAEC57-A49A-7767-069B-2F8E7D2278F2}"/>
+              </a:ext>
+            </a:extLst>
+          </p:cNvPr>
+          <p:cNvSpPr/>
+          <p:nvPr/>
+        </p:nvSpPr>
+        <p:spPr>
+          <a:xfrm>
+            <a:off x="5006788" y="2554942"/>
+            <a:ext cx="3429000" cy="874058"/>
+          </a:xfrm>
+          <a:prstGeom prst="rect">
+            <a:avLst/>
+          </a:prstGeom>
+          <a:noFill/>
+          <a:ln>
+            <a:solidFill>
+              <a:schemeClr val="accent3"/>
+            </a:solidFill>
+          </a:ln>
+        </p:spPr>
+        <p:style>
+          <a:lnRef idx="2">
+            <a:schemeClr val="accent1">
+              <a:shade val="15000"/>
+            </a:schemeClr>
+          </a:lnRef>
+          <a:fillRef idx="1">
+            <a:schemeClr val="accent1"/>
+          </a:fillRef>
+          <a:effectRef idx="0">
+            <a:schemeClr val="accent1"/>
+          </a:effectRef>
+          <a:fontRef idx="minor">
+            <a:schemeClr val="lt1"/>
+          </a:fontRef>
+        </p:style>
+        <p:txBody>
+          <a:bodyPr rtlCol="0" anchor="ctr"/>
+          <a:lstStyle/>
+          <a:p>
+            <a:pPr algn="ctr"/>
+            <a:r>
+              <a:rPr lang="en-US" b="1" dirty="0">
+                <a:solidFill>
+                  <a:schemeClr val="tx1"/>
+                </a:solidFill>
+              </a:rPr>
+              <a:t>True negative (TN)</a:t>
+            </a:r>
+          </a:p>
+          <a:p>
+            <a:pPr algn="ctr"/>
+            <a:r>
+              <a:rPr lang="en-US" b="1" dirty="0">
+                <a:solidFill>
+                  <a:schemeClr val="tx1"/>
+                </a:solidFill>
+              </a:rPr>
+              <a:t>….</a:t>
+            </a:r>
+          </a:p>
+        </p:txBody>
+      </p:sp>
+    </p:spTree>
+    <p:extLst>
+      <p:ext uri="{BB962C8B-B14F-4D97-AF65-F5344CB8AC3E}">
+        <p14:creationId xmlns:p14="http://schemas.microsoft.com/office/powerpoint/2010/main" val="2596127640"/>
       </p:ext>
     </p:extLst>
   </p:cSld>

</xml_diff>